<commit_message>
Expand 4-min deck to 7 slides (add explosion + source-criticism slides)
Co-Authored-By: Claude Opus 4.8 <noreply@anthropic.com>
</commit_message>
<xml_diff>
--- a/ai_discourse_4min.pptx
+++ b/ai_discourse_4min.pptx
@@ -10,6 +10,8 @@
     <p:sldId id="258" r:id="rId9"/>
     <p:sldId id="259" r:id="rId10"/>
     <p:sldId id="260" r:id="rId11"/>
+    <p:sldId id="261" r:id="rId12"/>
+    <p:sldId id="262" r:id="rId13"/>
   </p:sldIdLst>
   <p:sldSz cx="12191695" cy="6858000" type="screen4x3"/>
   <p:notesSz cx="6858000" cy="9144000"/>
@@ -576,7 +578,7 @@
           <a:lstStyle/>
           <a:p>
             <a:r>
-              <a:t>My hook is Kate Crawford's Atlas of AI. She argues AI is a system of power — but it's a qualitative argument; she never shows computationally WHEN the discourse shifted or how fast. That's my gap: 30 years of book data plus 13 years of global news data. And I flip the usual question — not what AI can do for historians, but what historians can do with AI discourse as a primary source. [~55s]</a:t>
+              <a:t>My hook is Kate Crawford's Atlas of AI. She argues AI is a system of power — but it's a qualitative argument; she never shows computationally WHEN the discourse shifted or how fast. That's my gap: 30 years of book data plus 13 years of global news data. And I flip the usual question — not what AI can do for historians, but what historians can do with AI discourse as a primary source. [~45s]</a:t>
             </a:r>
           </a:p>
         </p:txBody>
@@ -646,7 +648,7 @@
           <a:lstStyle/>
           <a:p>
             <a:r>
-              <a:t>Finding one, and it's a surprise: AI didn't just grow. It DECLINED in the 1990s — the AI Winter — and 'machine learning' overtook it by 2013, as the field rebranded. THEN it exploded: after AlphaGo and ChatGPT, AI reached about 1% of all news coverage in 2023. [~55s]</a:t>
+              <a:t>Finding one, and it's a surprise: AI didn't just grow. It DECLINED in the 1990s — the AI Winter — and 'machine learning' overtook it by 2013, as the field quietly rebranded around concrete method. [~40s]</a:t>
             </a:r>
           </a:p>
         </p:txBody>
@@ -716,7 +718,7 @@
           <a:lstStyle/>
           <a:p>
             <a:r>
-              <a:t>Finding two — the twist I'm proudest of. The conventional story is optimism turning to fear. But the tone of AI coverage was negative every single year, even back in 2010. There was no golden age of optimism to lose. So the real shift wasn't sentiment — it was SCALE and POLITICAL SALIENCE: AI went from a scientific keyword to a geopolitical one, tied to US-China competition and existential risk. [~60s]</a:t>
+              <a:t>Finding two: then the explosion. After AlphaGo and ChatGPT, AI's SHARE of all news more than doubled — to about 1% in 2023. And I control for the total growth of news, so this is a real shift in attention, not just more articles being published. [~40s]</a:t>
             </a:r>
           </a:p>
         </p:txBody>
@@ -786,7 +788,147 @@
           <a:lstStyle/>
           <a:p>
             <a:r>
-              <a:t>It's all a live web exhibit — five charts, a robustness check against a second dataset, and full source criticism, including why I rejected GDELT's raw counts. Please go explore it, and tell me where the argument is weak — I'd genuinely love your pushback. Thank you. [~30s]</a:t>
+              <a:t>Finding three — the twist I'm proudest of. The conventional story is optimism turning to fear. But the tone of AI coverage was negative every single year, even back in 2010. There was no golden age of optimism to lose. So the real shift wasn't sentiment — it was SCALE and POLITICAL SALIENCE: AI went from a scientific keyword to a geopolitical one, tied to US-China competition and existential risk. [~50s]</a:t>
+            </a:r>
+          </a:p>
+        </p:txBody>
+      </p:sp>
+      <p:sp>
+        <p:nvSpPr>
+          <p:cNvPr id="4" name="Slide Number Placeholder 3"/>
+          <p:cNvSpPr>
+            <a:spLocks noGrp="1"/>
+          </p:cNvSpPr>
+          <p:nvPr>
+            <p:ph type="sldNum" idx="5" sz="quarter"/>
+          </p:nvPr>
+        </p:nvSpPr>
+        <p:spPr/>
+      </p:sp>
+    </p:spTree>
+  </p:cSld>
+  <p:clrMapOvr>
+    <a:masterClrMapping/>
+  </p:clrMapOvr>
+</p:notes>
+</file>
+
+<file path=ppt/notesSlides/notesSlide6.xml><?xml version="1.0" encoding="utf-8"?>
+<p:notes xmlns:a="http://schemas.openxmlformats.org/drawingml/2006/main" xmlns:p="http://schemas.openxmlformats.org/presentationml/2006/main" xmlns:r="http://schemas.openxmlformats.org/officeDocument/2006/relationships">
+  <p:cSld>
+    <p:spTree>
+      <p:nvGrpSpPr>
+        <p:cNvPr id="1" name=""/>
+        <p:cNvGrpSpPr/>
+        <p:nvPr/>
+      </p:nvGrpSpPr>
+      <p:grpSpPr>
+        <a:xfrm>
+          <a:off x="0" y="0"/>
+          <a:ext cx="0" cy="0"/>
+          <a:chOff x="0" y="0"/>
+          <a:chExt cx="0" cy="0"/>
+        </a:xfrm>
+      </p:grpSpPr>
+      <p:sp>
+        <p:nvSpPr>
+          <p:cNvPr id="2" name="Slide Image Placeholder 1"/>
+          <p:cNvSpPr>
+            <a:spLocks noGrp="1"/>
+          </p:cNvSpPr>
+          <p:nvPr>
+            <p:ph type="sldImg" idx="2"/>
+          </p:nvPr>
+        </p:nvSpPr>
+        <p:spPr/>
+      </p:sp>
+      <p:sp>
+        <p:nvSpPr>
+          <p:cNvPr id="3" name="Notes Placeholder 2"/>
+          <p:cNvSpPr>
+            <a:spLocks noGrp="1"/>
+          </p:cNvSpPr>
+          <p:nvPr>
+            <p:ph type="body" idx="3" sz="quarter"/>
+          </p:nvPr>
+        </p:nvSpPr>
+        <p:spPr/>
+        <p:txBody>
+          <a:bodyPr/>
+          <a:lstStyle/>
+          <a:p>
+            <a:r>
+              <a:t>One methodological point I'm proud of. I almost used GDELT as my main news source — but its AI counts jump from 347, to 53,000, to 3.9 MILLION in two years. That's not AI exploding; it's the database expanding its own sources in 2015. The instrument changed, not the world. Catching that — source criticism — is the real scholarship. [~35s]</a:t>
+            </a:r>
+          </a:p>
+        </p:txBody>
+      </p:sp>
+      <p:sp>
+        <p:nvSpPr>
+          <p:cNvPr id="4" name="Slide Number Placeholder 3"/>
+          <p:cNvSpPr>
+            <a:spLocks noGrp="1"/>
+          </p:cNvSpPr>
+          <p:nvPr>
+            <p:ph type="sldNum" idx="5" sz="quarter"/>
+          </p:nvPr>
+        </p:nvSpPr>
+        <p:spPr/>
+      </p:sp>
+    </p:spTree>
+  </p:cSld>
+  <p:clrMapOvr>
+    <a:masterClrMapping/>
+  </p:clrMapOvr>
+</p:notes>
+</file>
+
+<file path=ppt/notesSlides/notesSlide7.xml><?xml version="1.0" encoding="utf-8"?>
+<p:notes xmlns:a="http://schemas.openxmlformats.org/drawingml/2006/main" xmlns:p="http://schemas.openxmlformats.org/presentationml/2006/main" xmlns:r="http://schemas.openxmlformats.org/officeDocument/2006/relationships">
+  <p:cSld>
+    <p:spTree>
+      <p:nvGrpSpPr>
+        <p:cNvPr id="1" name=""/>
+        <p:cNvGrpSpPr/>
+        <p:nvPr/>
+      </p:nvGrpSpPr>
+      <p:grpSpPr>
+        <a:xfrm>
+          <a:off x="0" y="0"/>
+          <a:ext cx="0" cy="0"/>
+          <a:chOff x="0" y="0"/>
+          <a:chExt cx="0" cy="0"/>
+        </a:xfrm>
+      </p:grpSpPr>
+      <p:sp>
+        <p:nvSpPr>
+          <p:cNvPr id="2" name="Slide Image Placeholder 1"/>
+          <p:cNvSpPr>
+            <a:spLocks noGrp="1"/>
+          </p:cNvSpPr>
+          <p:nvPr>
+            <p:ph type="sldImg" idx="2"/>
+          </p:nvPr>
+        </p:nvSpPr>
+        <p:spPr/>
+      </p:sp>
+      <p:sp>
+        <p:nvSpPr>
+          <p:cNvPr id="3" name="Notes Placeholder 2"/>
+          <p:cNvSpPr>
+            <a:spLocks noGrp="1"/>
+          </p:cNvSpPr>
+          <p:nvPr>
+            <p:ph type="body" idx="3" sz="quarter"/>
+          </p:nvPr>
+        </p:nvSpPr>
+        <p:spPr/>
+        <p:txBody>
+          <a:bodyPr/>
+          <a:lstStyle/>
+          <a:p>
+            <a:r>
+              <a:t>It's all a live web exhibit — with a robustness check against a second dataset and full source criticism. Please go explore it, and tell me where the argument is weak — I'd genuinely love your pushback. Thank you. [~25s]</a:t>
             </a:r>
           </a:p>
         </p:txBody>
@@ -4509,7 +4651,7 @@
                 </a:solidFill>
                 <a:latin typeface="Calibri"/>
               </a:rPr>
-              <a:t>“Artificial intelligence” DECLINED in the 1990s — the AI Winter; “machine learning” overtook it by 2013</a:t>
+              <a:t>“Artificial intelligence” DECLINED in the 1990s — the AI Winter</a:t>
             </a:r>
           </a:p>
           <a:p>
@@ -4533,11 +4675,11 @@
             <a:r>
               <a:rPr sz="1600">
                 <a:solidFill>
-                  <a:srgbClr val="7E4FA8"/>
+                  <a:srgbClr val="E74C3C"/>
                 </a:solidFill>
                 <a:latin typeface="Calibri"/>
               </a:rPr>
-              <a:t>Then it exploded: after AlphaGo (2016) and ChatGPT (2022), AI hit ~1% of ALL news in 2023</a:t>
+              <a:t>“Machine learning” rose and overtook it by 2013 — the field quietly rebranded around concrete method</a:t>
             </a:r>
           </a:p>
         </p:txBody>
@@ -4670,7 +4812,258 @@
                 </a:solidFill>
                 <a:latin typeface="Calibri"/>
               </a:rPr>
-              <a:t>FINDING 2 · THE TWIST</a:t>
+              <a:t>FINDING 2</a:t>
+            </a:r>
+          </a:p>
+        </p:txBody>
+      </p:sp>
+      <p:sp>
+        <p:nvSpPr>
+          <p:cNvPr id="4" name="TextBox 3"/>
+          <p:cNvSpPr txBox="1"/>
+          <p:nvPr/>
+        </p:nvSpPr>
+        <p:spPr>
+          <a:xfrm>
+            <a:off x="868680" y="749808"/>
+            <a:ext cx="10881360" cy="731520"/>
+          </a:xfrm>
+          <a:prstGeom prst="rect">
+            <a:avLst/>
+          </a:prstGeom>
+          <a:noFill/>
+        </p:spPr>
+        <p:txBody>
+          <a:bodyPr wrap="square" anchor="t">
+            <a:spAutoFit/>
+          </a:bodyPr>
+          <a:lstStyle/>
+          <a:p>
+            <a:pPr algn="l">
+              <a:lnSpc>
+                <a:spcPct val="100000"/>
+              </a:lnSpc>
+            </a:pPr>
+            <a:r>
+              <a:rPr sz="3000" b="1" i="0">
+                <a:solidFill>
+                  <a:srgbClr val="1A1D24"/>
+                </a:solidFill>
+                <a:latin typeface="Calibri"/>
+              </a:rPr>
+              <a:t>Then the explosion — and it's real</a:t>
+            </a:r>
+          </a:p>
+        </p:txBody>
+      </p:sp>
+      <p:sp>
+        <p:nvSpPr>
+          <p:cNvPr id="5" name="TextBox 4"/>
+          <p:cNvSpPr txBox="1"/>
+          <p:nvPr/>
+        </p:nvSpPr>
+        <p:spPr>
+          <a:xfrm>
+            <a:off x="868680" y="1572768"/>
+            <a:ext cx="10607040" cy="914400"/>
+          </a:xfrm>
+          <a:prstGeom prst="rect">
+            <a:avLst/>
+          </a:prstGeom>
+          <a:noFill/>
+        </p:spPr>
+        <p:txBody>
+          <a:bodyPr wrap="square">
+            <a:spAutoFit/>
+          </a:bodyPr>
+          <a:lstStyle/>
+          <a:p>
+            <a:pPr>
+              <a:lnSpc>
+                <a:spcPct val="105000"/>
+              </a:lnSpc>
+              <a:spcAft>
+                <a:spcPts val="1200"/>
+              </a:spcAft>
+            </a:pPr>
+            <a:r>
+              <a:rPr sz="1600" b="1">
+                <a:solidFill>
+                  <a:srgbClr val="B8860B"/>
+                </a:solidFill>
+                <a:latin typeface="Calibri"/>
+              </a:rPr>
+              <a:t>•  </a:t>
+            </a:r>
+            <a:r>
+              <a:rPr sz="1600">
+                <a:solidFill>
+                  <a:srgbClr val="7E4FA8"/>
+                </a:solidFill>
+                <a:latin typeface="Calibri"/>
+              </a:rPr>
+              <a:t>After AlphaGo (2016) and ChatGPT (2022), AI’s SHARE of all news more than doubled — to ~1% in 2023</a:t>
+            </a:r>
+          </a:p>
+          <a:p>
+            <a:pPr>
+              <a:lnSpc>
+                <a:spcPct val="105000"/>
+              </a:lnSpc>
+              <a:spcAft>
+                <a:spcPts val="1200"/>
+              </a:spcAft>
+            </a:pPr>
+            <a:r>
+              <a:rPr sz="1600" b="1">
+                <a:solidFill>
+                  <a:srgbClr val="B8860B"/>
+                </a:solidFill>
+                <a:latin typeface="Calibri"/>
+              </a:rPr>
+              <a:t>•  </a:t>
+            </a:r>
+            <a:r>
+              <a:rPr sz="1600">
+                <a:solidFill>
+                  <a:srgbClr val="1A1D24"/>
+                </a:solidFill>
+                <a:latin typeface="Calibri"/>
+              </a:rPr>
+              <a:t>I control for total news growth, so this is a genuine shift in attention, not just “more news”</a:t>
+            </a:r>
+          </a:p>
+        </p:txBody>
+      </p:sp>
+      <p:pic>
+        <p:nvPicPr>
+          <p:cNvPr id="6" name="Picture 5" descr="panel3_share.png"/>
+          <p:cNvPicPr>
+            <a:picLocks noChangeAspect="1"/>
+          </p:cNvPicPr>
+          <p:nvPr/>
+        </p:nvPicPr>
+        <p:blipFill>
+          <a:blip r:embed="rId2"/>
+          <a:stretch>
+            <a:fillRect/>
+          </a:stretch>
+        </p:blipFill>
+        <p:spPr>
+          <a:xfrm>
+            <a:off x="1996384" y="2651760"/>
+            <a:ext cx="8198927" cy="4023360"/>
+          </a:xfrm>
+          <a:prstGeom prst="rect">
+            <a:avLst/>
+          </a:prstGeom>
+        </p:spPr>
+      </p:pic>
+    </p:spTree>
+  </p:cSld>
+  <p:clrMapOvr>
+    <a:masterClrMapping/>
+  </p:clrMapOvr>
+</p:sld>
+</file>
+
+<file path=ppt/slides/slide5.xml><?xml version="1.0" encoding="utf-8"?>
+<p:sld xmlns:a="http://schemas.openxmlformats.org/drawingml/2006/main" xmlns:p="http://schemas.openxmlformats.org/presentationml/2006/main" xmlns:r="http://schemas.openxmlformats.org/officeDocument/2006/relationships">
+  <p:cSld>
+    <p:bg>
+      <p:bgPr>
+        <a:solidFill>
+          <a:srgbClr val="FFFFFF"/>
+        </a:solidFill>
+        <a:effectLst/>
+      </p:bgPr>
+    </p:bg>
+    <p:spTree>
+      <p:nvGrpSpPr>
+        <p:cNvPr id="1" name=""/>
+        <p:cNvGrpSpPr/>
+        <p:nvPr/>
+      </p:nvGrpSpPr>
+      <p:grpSpPr/>
+      <p:sp>
+        <p:nvSpPr>
+          <p:cNvPr id="2" name="Rectangle 1"/>
+          <p:cNvSpPr/>
+          <p:nvPr/>
+        </p:nvSpPr>
+        <p:spPr>
+          <a:xfrm>
+            <a:off x="548640" y="502920"/>
+            <a:ext cx="146304" cy="566928"/>
+          </a:xfrm>
+          <a:prstGeom prst="rect">
+            <a:avLst/>
+          </a:prstGeom>
+          <a:solidFill>
+            <a:srgbClr val="B8860B"/>
+          </a:solidFill>
+          <a:ln>
+            <a:noFill/>
+          </a:ln>
+          <a:effectLst/>
+        </p:spPr>
+        <p:style>
+          <a:lnRef idx="1">
+            <a:schemeClr val="accent1"/>
+          </a:lnRef>
+          <a:fillRef idx="3">
+            <a:schemeClr val="accent1"/>
+          </a:fillRef>
+          <a:effectRef idx="2">
+            <a:schemeClr val="accent1"/>
+          </a:effectRef>
+          <a:fontRef idx="minor">
+            <a:schemeClr val="lt1"/>
+          </a:fontRef>
+        </p:style>
+        <p:txBody>
+          <a:bodyPr rtlCol="0" anchor="ctr"/>
+          <a:lstStyle/>
+          <a:p>
+            <a:pPr algn="ctr"/>
+          </a:p>
+        </p:txBody>
+      </p:sp>
+      <p:sp>
+        <p:nvSpPr>
+          <p:cNvPr id="3" name="TextBox 2"/>
+          <p:cNvSpPr txBox="1"/>
+          <p:nvPr/>
+        </p:nvSpPr>
+        <p:spPr>
+          <a:xfrm>
+            <a:off x="868680" y="457200"/>
+            <a:ext cx="10607040" cy="365760"/>
+          </a:xfrm>
+          <a:prstGeom prst="rect">
+            <a:avLst/>
+          </a:prstGeom>
+          <a:noFill/>
+        </p:spPr>
+        <p:txBody>
+          <a:bodyPr wrap="square" anchor="t">
+            <a:spAutoFit/>
+          </a:bodyPr>
+          <a:lstStyle/>
+          <a:p>
+            <a:pPr algn="l">
+              <a:lnSpc>
+                <a:spcPct val="100000"/>
+              </a:lnSpc>
+            </a:pPr>
+            <a:r>
+              <a:rPr sz="1400" b="1" i="0">
+                <a:solidFill>
+                  <a:srgbClr val="B8860B"/>
+                </a:solidFill>
+                <a:latin typeface="Calibri"/>
+              </a:rPr>
+              <a:t>FINDING 3 · THE TWIST</a:t>
             </a:r>
           </a:p>
         </p:txBody>
@@ -4825,7 +5218,262 @@
 </p:sld>
 </file>
 
-<file path=ppt/slides/slide5.xml><?xml version="1.0" encoding="utf-8"?>
+<file path=ppt/slides/slide6.xml><?xml version="1.0" encoding="utf-8"?>
+<p:sld xmlns:a="http://schemas.openxmlformats.org/drawingml/2006/main" xmlns:p="http://schemas.openxmlformats.org/presentationml/2006/main" xmlns:r="http://schemas.openxmlformats.org/officeDocument/2006/relationships">
+  <p:cSld>
+    <p:bg>
+      <p:bgPr>
+        <a:solidFill>
+          <a:srgbClr val="FFFFFF"/>
+        </a:solidFill>
+        <a:effectLst/>
+      </p:bgPr>
+    </p:bg>
+    <p:spTree>
+      <p:nvGrpSpPr>
+        <p:cNvPr id="1" name=""/>
+        <p:cNvGrpSpPr/>
+        <p:nvPr/>
+      </p:nvGrpSpPr>
+      <p:grpSpPr/>
+      <p:sp>
+        <p:nvSpPr>
+          <p:cNvPr id="2" name="Rectangle 1"/>
+          <p:cNvSpPr/>
+          <p:nvPr/>
+        </p:nvSpPr>
+        <p:spPr>
+          <a:xfrm>
+            <a:off x="548640" y="502920"/>
+            <a:ext cx="146304" cy="566928"/>
+          </a:xfrm>
+          <a:prstGeom prst="rect">
+            <a:avLst/>
+          </a:prstGeom>
+          <a:solidFill>
+            <a:srgbClr val="B8860B"/>
+          </a:solidFill>
+          <a:ln>
+            <a:noFill/>
+          </a:ln>
+          <a:effectLst/>
+        </p:spPr>
+        <p:style>
+          <a:lnRef idx="1">
+            <a:schemeClr val="accent1"/>
+          </a:lnRef>
+          <a:fillRef idx="3">
+            <a:schemeClr val="accent1"/>
+          </a:fillRef>
+          <a:effectRef idx="2">
+            <a:schemeClr val="accent1"/>
+          </a:effectRef>
+          <a:fontRef idx="minor">
+            <a:schemeClr val="lt1"/>
+          </a:fontRef>
+        </p:style>
+        <p:txBody>
+          <a:bodyPr rtlCol="0" anchor="ctr"/>
+          <a:lstStyle/>
+          <a:p>
+            <a:pPr algn="ctr"/>
+          </a:p>
+        </p:txBody>
+      </p:sp>
+      <p:sp>
+        <p:nvSpPr>
+          <p:cNvPr id="3" name="TextBox 2"/>
+          <p:cNvSpPr txBox="1"/>
+          <p:nvPr/>
+        </p:nvSpPr>
+        <p:spPr>
+          <a:xfrm>
+            <a:off x="868680" y="457200"/>
+            <a:ext cx="10607040" cy="365760"/>
+          </a:xfrm>
+          <a:prstGeom prst="rect">
+            <a:avLst/>
+          </a:prstGeom>
+          <a:noFill/>
+        </p:spPr>
+        <p:txBody>
+          <a:bodyPr wrap="square" anchor="t">
+            <a:spAutoFit/>
+          </a:bodyPr>
+          <a:lstStyle/>
+          <a:p>
+            <a:pPr algn="l">
+              <a:lnSpc>
+                <a:spcPct val="100000"/>
+              </a:lnSpc>
+            </a:pPr>
+            <a:r>
+              <a:rPr sz="1400" b="1" i="0">
+                <a:solidFill>
+                  <a:srgbClr val="B8860B"/>
+                </a:solidFill>
+                <a:latin typeface="Calibri"/>
+              </a:rPr>
+              <a:t>WHY IT'S RIGOROUS</a:t>
+            </a:r>
+          </a:p>
+        </p:txBody>
+      </p:sp>
+      <p:sp>
+        <p:nvSpPr>
+          <p:cNvPr id="4" name="TextBox 3"/>
+          <p:cNvSpPr txBox="1"/>
+          <p:nvPr/>
+        </p:nvSpPr>
+        <p:spPr>
+          <a:xfrm>
+            <a:off x="868680" y="749808"/>
+            <a:ext cx="10881360" cy="731520"/>
+          </a:xfrm>
+          <a:prstGeom prst="rect">
+            <a:avLst/>
+          </a:prstGeom>
+          <a:noFill/>
+        </p:spPr>
+        <p:txBody>
+          <a:bodyPr wrap="square" anchor="t">
+            <a:spAutoFit/>
+          </a:bodyPr>
+          <a:lstStyle/>
+          <a:p>
+            <a:pPr algn="l">
+              <a:lnSpc>
+                <a:spcPct val="100000"/>
+              </a:lnSpc>
+            </a:pPr>
+            <a:r>
+              <a:rPr sz="3000" b="1" i="0">
+                <a:solidFill>
+                  <a:srgbClr val="1A1D24"/>
+                </a:solidFill>
+                <a:latin typeface="Calibri"/>
+              </a:rPr>
+              <a:t>I rejected a source — on purpose</a:t>
+            </a:r>
+          </a:p>
+        </p:txBody>
+      </p:sp>
+      <p:sp>
+        <p:nvSpPr>
+          <p:cNvPr id="5" name="TextBox 4"/>
+          <p:cNvSpPr txBox="1"/>
+          <p:nvPr/>
+        </p:nvSpPr>
+        <p:spPr>
+          <a:xfrm>
+            <a:off x="1051560" y="1874519"/>
+            <a:ext cx="10332720" cy="3657600"/>
+          </a:xfrm>
+          <a:prstGeom prst="rect">
+            <a:avLst/>
+          </a:prstGeom>
+          <a:noFill/>
+        </p:spPr>
+        <p:txBody>
+          <a:bodyPr wrap="square">
+            <a:spAutoFit/>
+          </a:bodyPr>
+          <a:lstStyle/>
+          <a:p>
+            <a:pPr>
+              <a:lnSpc>
+                <a:spcPct val="105000"/>
+              </a:lnSpc>
+              <a:spcAft>
+                <a:spcPts val="2000"/>
+              </a:spcAft>
+            </a:pPr>
+            <a:r>
+              <a:rPr sz="2100" b="1">
+                <a:solidFill>
+                  <a:srgbClr val="B8860B"/>
+                </a:solidFill>
+                <a:latin typeface="Calibri"/>
+              </a:rPr>
+              <a:t>•  </a:t>
+            </a:r>
+            <a:r>
+              <a:rPr sz="2100">
+                <a:solidFill>
+                  <a:srgbClr val="1A1D24"/>
+                </a:solidFill>
+                <a:latin typeface="Calibri"/>
+              </a:rPr>
+              <a:t>I almost used GDELT — but its AI counts jump 347 → 53,000 → 3.9 MILLION in just two years</a:t>
+            </a:r>
+          </a:p>
+          <a:p>
+            <a:pPr>
+              <a:lnSpc>
+                <a:spcPct val="105000"/>
+              </a:lnSpc>
+              <a:spcAft>
+                <a:spcPts val="2000"/>
+              </a:spcAft>
+            </a:pPr>
+            <a:r>
+              <a:rPr sz="2100" b="1">
+                <a:solidFill>
+                  <a:srgbClr val="B8860B"/>
+                </a:solidFill>
+                <a:latin typeface="Calibri"/>
+              </a:rPr>
+              <a:t>•  </a:t>
+            </a:r>
+            <a:r>
+              <a:rPr sz="2100">
+                <a:solidFill>
+                  <a:srgbClr val="E74C3C"/>
+                </a:solidFill>
+                <a:latin typeface="Calibri"/>
+              </a:rPr>
+              <a:t>That’s the database expanding its sources in 2015 — the instrument changed, not the world</a:t>
+            </a:r>
+          </a:p>
+          <a:p>
+            <a:pPr>
+              <a:lnSpc>
+                <a:spcPct val="105000"/>
+              </a:lnSpc>
+              <a:spcAft>
+                <a:spcPts val="2000"/>
+              </a:spcAft>
+            </a:pPr>
+            <a:r>
+              <a:rPr sz="2100" b="1">
+                <a:solidFill>
+                  <a:srgbClr val="B8860B"/>
+                </a:solidFill>
+                <a:latin typeface="Calibri"/>
+              </a:rPr>
+              <a:t>•  </a:t>
+            </a:r>
+            <a:r>
+              <a:rPr sz="2100">
+                <a:solidFill>
+                  <a:srgbClr val="5B6470"/>
+                </a:solidFill>
+                <a:latin typeface="Calibri"/>
+              </a:rPr>
+              <a:t>Catching that — source criticism — is the real scholarship behind the project</a:t>
+            </a:r>
+          </a:p>
+        </p:txBody>
+      </p:sp>
+    </p:spTree>
+  </p:cSld>
+  <p:clrMapOvr>
+    <a:masterClrMapping/>
+  </p:clrMapOvr>
+</p:sld>
+</file>
+
+<file path=ppt/slides/slide7.xml><?xml version="1.0" encoding="utf-8"?>
 <p:sld xmlns:a="http://schemas.openxmlformats.org/drawingml/2006/main" xmlns:p="http://schemas.openxmlformats.org/presentationml/2006/main" xmlns:r="http://schemas.openxmlformats.org/officeDocument/2006/relationships">
   <p:cSld>
     <p:bg>

</xml_diff>

<commit_message>
Swap rejection slide for a results-forward robustness slide in 4-min deck
Co-Authored-By: Claude Opus 4.8 <noreply@anthropic.com>
</commit_message>
<xml_diff>
--- a/ai_discourse_4min.pptx
+++ b/ai_discourse_4min.pptx
@@ -858,7 +858,7 @@
           <a:lstStyle/>
           <a:p>
             <a:r>
-              <a:t>One methodological point I'm proud of. I almost used GDELT as my main news source — but its AI counts jump from 347, to 53,000, to 3.9 MILLION in two years. That's not AI exploding; it's the database expanding its own sources in 2015. The instrument changed, not the world. Catching that — source criticism — is the real scholarship. [~35s]</a:t>
+              <a:t>And does it hold up? To make sure that 2023 spike is real and not a quirk of my data, I checked it against a completely separate news database. The two track each other closely and in 2023 land at almost exactly the same value — so I'm confident the surge is real. [~35s]</a:t>
             </a:r>
           </a:p>
         </p:txBody>
@@ -928,7 +928,7 @@
           <a:lstStyle/>
           <a:p>
             <a:r>
-              <a:t>It's all a live web exhibit — with a robustness check against a second dataset and full source criticism. Please go explore it, and tell me where the argument is weak — I'd genuinely love your pushback. Thank you. [~25s]</a:t>
+              <a:t>It's all a live web exhibit, with more charts and the full method behind it. Please go explore it, and tell me where the argument is weak — I'd genuinely love your pushback. Thank you. [~25s]</a:t>
             </a:r>
           </a:p>
         </p:txBody>
@@ -5314,7 +5314,7 @@
                 </a:solidFill>
                 <a:latin typeface="Calibri"/>
               </a:rPr>
-              <a:t>WHY IT'S RIGOROUS</a:t>
+              <a:t>DOES IT HOLD UP?</a:t>
             </a:r>
           </a:p>
         </p:txBody>
@@ -5353,7 +5353,7 @@
                 </a:solidFill>
                 <a:latin typeface="Calibri"/>
               </a:rPr>
-              <a:t>I rejected a source — on purpose</a:t>
+              <a:t>A second source agrees</a:t>
             </a:r>
           </a:p>
         </p:txBody>
@@ -5366,8 +5366,8 @@
         </p:nvSpPr>
         <p:spPr>
           <a:xfrm>
-            <a:off x="1051560" y="1874519"/>
-            <a:ext cx="10332720" cy="3657600"/>
+            <a:off x="868680" y="1572768"/>
+            <a:ext cx="10607040" cy="914400"/>
           </a:xfrm>
           <a:prstGeom prst="rect">
             <a:avLst/>
@@ -5385,11 +5385,11 @@
                 <a:spcPct val="105000"/>
               </a:lnSpc>
               <a:spcAft>
-                <a:spcPts val="2000"/>
+                <a:spcPts val="1200"/>
               </a:spcAft>
             </a:pPr>
             <a:r>
-              <a:rPr sz="2100" b="1">
+              <a:rPr sz="1600" b="1">
                 <a:solidFill>
                   <a:srgbClr val="B8860B"/>
                 </a:solidFill>
@@ -5398,13 +5398,13 @@
               <a:t>•  </a:t>
             </a:r>
             <a:r>
-              <a:rPr sz="2100">
+              <a:rPr sz="1600">
                 <a:solidFill>
                   <a:srgbClr val="1A1D24"/>
                 </a:solidFill>
                 <a:latin typeface="Calibri"/>
               </a:rPr>
-              <a:t>I almost used GDELT — but its AI counts jump 347 → 53,000 → 3.9 MILLION in just two years</a:t>
+              <a:t>To check the 2023 spike is real, I compared it against a separate news database</a:t>
             </a:r>
           </a:p>
           <a:p>
@@ -5413,11 +5413,11 @@
                 <a:spcPct val="105000"/>
               </a:lnSpc>
               <a:spcAft>
-                <a:spcPts val="2000"/>
+                <a:spcPts val="1200"/>
               </a:spcAft>
             </a:pPr>
             <a:r>
-              <a:rPr sz="2100" b="1">
+              <a:rPr sz="1600" b="1">
                 <a:solidFill>
                   <a:srgbClr val="B8860B"/>
                 </a:solidFill>
@@ -5426,45 +5426,41 @@
               <a:t>•  </a:t>
             </a:r>
             <a:r>
-              <a:rPr sz="2100">
+              <a:rPr sz="1600">
                 <a:solidFill>
-                  <a:srgbClr val="E74C3C"/>
+                  <a:srgbClr val="7E4FA8"/>
                 </a:solidFill>
                 <a:latin typeface="Calibri"/>
               </a:rPr>
-              <a:t>That’s the database expanding its sources in 2015 — the instrument changed, not the world</a:t>
-            </a:r>
-          </a:p>
-          <a:p>
-            <a:pPr>
-              <a:lnSpc>
-                <a:spcPct val="105000"/>
-              </a:lnSpc>
-              <a:spcAft>
-                <a:spcPts val="2000"/>
-              </a:spcAft>
-            </a:pPr>
-            <a:r>
-              <a:rPr sz="2100" b="1">
-                <a:solidFill>
-                  <a:srgbClr val="B8860B"/>
-                </a:solidFill>
-                <a:latin typeface="Calibri"/>
-              </a:rPr>
-              <a:t>•  </a:t>
-            </a:r>
-            <a:r>
-              <a:rPr sz="2100">
-                <a:solidFill>
-                  <a:srgbClr val="5B6470"/>
-                </a:solidFill>
-                <a:latin typeface="Calibri"/>
-              </a:rPr>
-              <a:t>Catching that — source criticism — is the real scholarship behind the project</a:t>
-            </a:r>
-          </a:p>
-        </p:txBody>
-      </p:sp>
+              <a:t>The two track closely and land at nearly the same value in 2023 — the surge isn’t a fluke of my data</a:t>
+            </a:r>
+          </a:p>
+        </p:txBody>
+      </p:sp>
+      <p:pic>
+        <p:nvPicPr>
+          <p:cNvPr id="6" name="Picture 5" descr="panel4_robustness.png"/>
+          <p:cNvPicPr>
+            <a:picLocks noChangeAspect="1"/>
+          </p:cNvPicPr>
+          <p:nvPr/>
+        </p:nvPicPr>
+        <p:blipFill>
+          <a:blip r:embed="rId2"/>
+          <a:stretch>
+            <a:fillRect/>
+          </a:stretch>
+        </p:blipFill>
+        <p:spPr>
+          <a:xfrm>
+            <a:off x="1996384" y="2651760"/>
+            <a:ext cx="8198927" cy="4023360"/>
+          </a:xfrm>
+          <a:prstGeom prst="rect">
+            <a:avLst/>
+          </a:prstGeom>
+        </p:spPr>
+      </p:pic>
     </p:spTree>
   </p:cSld>
   <p:clrMapOvr>

</xml_diff>

<commit_message>
Rewrite 4-min deck + script in simple English for the audience
Co-Authored-By: Claude Opus 4.8 <noreply@anthropic.com>
</commit_message>
<xml_diff>
--- a/ai_discourse_4min.pptx
+++ b/ai_discourse_4min.pptx
@@ -508,7 +508,7 @@
           <a:lstStyle/>
           <a:p>
             <a:r>
-              <a:t>Hi — my DH project asks a simple question: when did 'AI' become inescapable, and was it ever the hopeful story we assume? I trace how we've talked about AI for thirty years — in books and in the news. [~20s]</a:t>
+              <a:t>Hello. My project is about AI — but not the technology. It is about how people TALK about AI. I looked at 30 years of books and news. My question is simple: when did AI become a big topic? And were people ever happy about it? [~20s]</a:t>
             </a:r>
           </a:p>
         </p:txBody>
@@ -578,7 +578,7 @@
           <a:lstStyle/>
           <a:p>
             <a:r>
-              <a:t>My hook is Kate Crawford's Atlas of AI. She argues AI is a system of power — but it's a qualitative argument; she never shows computationally WHEN the discourse shifted or how fast. That's my gap: 30 years of book data plus 13 years of global news data. And I flip the usual question — not what AI can do for historians, but what historians can do with AI discourse as a primary source. [~45s]</a:t>
+              <a:t>A famous scholar, Kate Crawford, says AI is really about power and control. But she uses ideas, not data. She does not show WHEN people's view of AI changed. So I use data: 30 years of books, and 13 years of news from around the world. I use old AI news as evidence about history. [~45s]</a:t>
             </a:r>
           </a:p>
         </p:txBody>
@@ -648,7 +648,7 @@
           <a:lstStyle/>
           <a:p>
             <a:r>
-              <a:t>Finding one, and it's a surprise: AI didn't just grow. It DECLINED in the 1990s — the AI Winter — and 'machine learning' overtook it by 2013, as the field quietly rebranded around concrete method. [~40s]</a:t>
+              <a:t>My first finding is a surprise. In the 1990s, the word 'artificial intelligence' went DOWN in books. People lost interest. Then a new word, 'machine learning,' became more popular. By 2013, it passed 'artificial intelligence.' So the field changed its name. [~40s]</a:t>
             </a:r>
           </a:p>
         </p:txBody>
@@ -718,7 +718,7 @@
           <a:lstStyle/>
           <a:p>
             <a:r>
-              <a:t>Finding two: then the explosion. After AlphaGo and ChatGPT, AI's SHARE of all news more than doubled — to about 1% in 2023. And I control for the total growth of news, so this is a real shift in attention, not just more articles being published. [~40s]</a:t>
+              <a:t>My second finding: after 2016 and 2022 — after AlphaGo and ChatGPT — AI news exploded. In 2023, about 1 percent of ALL news in the world was about AI. Of course, there is more news today in general. But even so, AI grew much, much faster. People really paid more attention to AI. [~40s]</a:t>
             </a:r>
           </a:p>
         </p:txBody>
@@ -788,7 +788,7 @@
           <a:lstStyle/>
           <a:p>
             <a:r>
-              <a:t>Finding three — the twist I'm proudest of. The conventional story is optimism turning to fear. But the tone of AI coverage was negative every single year, even back in 2010. There was no golden age of optimism to lose. So the real shift wasn't sentiment — it was SCALE and POLITICAL SALIENCE: AI went from a scientific keyword to a geopolitical one, tied to US-China competition and existential risk. [~50s]</a:t>
+              <a:t>Now the surprising part. Many people think: first we were happy about AI, then we became afraid. But look. The news about AI was negative EVERY year — even in 2010. People were never really happy about AI. So the FEELING did not change. Two things changed. One: AI became a much BIGGER topic. Two: AI became a POLITICAL topic — about countries competing, like the US and China, and about danger and control. [~50s]</a:t>
             </a:r>
           </a:p>
         </p:txBody>
@@ -858,7 +858,7 @@
           <a:lstStyle/>
           <a:p>
             <a:r>
-              <a:t>And does it hold up? To make sure that 2023 spike is real and not a quirk of my data, I checked it against a completely separate news database. The two track each other closely and in 2023 land at almost exactly the same value — so I'm confident the surge is real. [~35s]</a:t>
+              <a:t>Is this real, or just a mistake in my data? To check, I used a different news database. The two databases show almost the same result. So I am sure: the big rise in 2023 is real. [~35s]</a:t>
             </a:r>
           </a:p>
         </p:txBody>
@@ -928,7 +928,7 @@
           <a:lstStyle/>
           <a:p>
             <a:r>
-              <a:t>It's all a live web exhibit, with more charts and the full method behind it. Please go explore it, and tell me where the argument is weak — I'd genuinely love your pushback. Thank you. [~25s]</a:t>
+              <a:t>You can see everything on my website. Please look at it. And please share your questions and opinions — I really want to hear them. Thank you. [~25s]</a:t>
             </a:r>
           </a:p>
         </p:txBody>
@@ -4103,7 +4103,7 @@
                 </a:solidFill>
                 <a:latin typeface="Calibri"/>
               </a:rPr>
-              <a:t>From Scientific Optimism</a:t>
+              <a:t>How the World Talks About AI</a:t>
             </a:r>
           </a:p>
           <a:p>
@@ -4119,7 +4119,7 @@
                 </a:solidFill>
                 <a:latin typeface="Calibri"/>
               </a:rPr>
-              <a:t>to Geopolitical Anxiety</a:t>
+              <a:t>1990 – 2023</a:t>
             </a:r>
           </a:p>
         </p:txBody>
@@ -4158,7 +4158,7 @@
                 </a:solidFill>
                 <a:latin typeface="Calibri"/>
               </a:rPr>
-              <a:t>A Computational History of AI Discourse  ·  1990–2023</a:t>
+              <a:t>A history of AI in books and news</a:t>
             </a:r>
           </a:p>
         </p:txBody>
@@ -4306,7 +4306,7 @@
                 </a:solidFill>
                 <a:latin typeface="Calibri"/>
               </a:rPr>
-              <a:t>WHAT'S NEW</a:t>
+              <a:t>MY IDEA</a:t>
             </a:r>
           </a:p>
         </p:txBody>
@@ -4345,7 +4345,7 @@
                 </a:solidFill>
                 <a:latin typeface="Calibri"/>
               </a:rPr>
-              <a:t>Filling a gap in Crawford's Atlas of AI</a:t>
+              <a:t>Adding data to a famous book</a:t>
             </a:r>
           </a:p>
         </p:txBody>
@@ -4377,11 +4377,11 @@
                 <a:spcPct val="105000"/>
               </a:lnSpc>
               <a:spcAft>
-                <a:spcPts val="2000"/>
+                <a:spcPts val="2200"/>
               </a:spcAft>
             </a:pPr>
             <a:r>
-              <a:rPr sz="2100" b="1">
+              <a:rPr sz="2200" b="1">
                 <a:solidFill>
                   <a:srgbClr val="B8860B"/>
                 </a:solidFill>
@@ -4390,13 +4390,13 @@
               <a:t>•  </a:t>
             </a:r>
             <a:r>
-              <a:rPr sz="2100">
+              <a:rPr sz="2200">
                 <a:solidFill>
                   <a:srgbClr val="1A1D24"/>
                 </a:solidFill>
                 <a:latin typeface="Calibri"/>
               </a:rPr>
-              <a:t>Kate Crawford argues AI is a system of power — but qualitatively. She never shows WHEN public discourse shifted, or how fast.</a:t>
+              <a:t>A famous scholar, Kate Crawford, says AI is really about power — but she uses ideas, not data</a:t>
             </a:r>
           </a:p>
           <a:p>
@@ -4405,11 +4405,11 @@
                 <a:spcPct val="105000"/>
               </a:lnSpc>
               <a:spcAft>
-                <a:spcPts val="2000"/>
+                <a:spcPts val="2200"/>
               </a:spcAft>
             </a:pPr>
             <a:r>
-              <a:rPr sz="2100" b="1">
+              <a:rPr sz="2200" b="1">
                 <a:solidFill>
                   <a:srgbClr val="B8860B"/>
                 </a:solidFill>
@@ -4418,13 +4418,13 @@
               <a:t>•  </a:t>
             </a:r>
             <a:r>
-              <a:rPr sz="2100">
+              <a:rPr sz="2200">
                 <a:solidFill>
                   <a:srgbClr val="1A1D24"/>
                 </a:solidFill>
                 <a:latin typeface="Calibri"/>
               </a:rPr>
-              <a:t>I add the quantitative timeline: 30 years of books (Ngram) + 13 years of global news (Media Cloud, GDELT).</a:t>
+              <a:t>I use data: 30 years of books + 13 years of news from around the world</a:t>
             </a:r>
           </a:p>
           <a:p>
@@ -4433,11 +4433,11 @@
                 <a:spcPct val="105000"/>
               </a:lnSpc>
               <a:spcAft>
-                <a:spcPts val="2000"/>
+                <a:spcPts val="2200"/>
               </a:spcAft>
             </a:pPr>
             <a:r>
-              <a:rPr sz="2100" b="1">
+              <a:rPr sz="2200" b="1">
                 <a:solidFill>
                   <a:srgbClr val="B8860B"/>
                 </a:solidFill>
@@ -4446,13 +4446,13 @@
               <a:t>•  </a:t>
             </a:r>
             <a:r>
-              <a:rPr sz="2100">
+              <a:rPr sz="2200">
                 <a:solidFill>
                   <a:srgbClr val="1A1D24"/>
                 </a:solidFill>
                 <a:latin typeface="Calibri"/>
               </a:rPr>
-              <a:t>And I flip the question — not “what can AI do for historians?” but “what can historians do with AI discourse as a primary source?”</a:t>
+              <a:t>My question: WHEN did people’s view of AI change? I use old AI news as evidence</a:t>
             </a:r>
           </a:p>
         </p:txBody>
@@ -4600,7 +4600,7 @@
                 </a:solidFill>
                 <a:latin typeface="Calibri"/>
               </a:rPr>
-              <a:t>AI didn't just grow — it declined, then rebranded</a:t>
+              <a:t>First AI went down — then it changed its name</a:t>
             </a:r>
           </a:p>
         </p:txBody>
@@ -4651,7 +4651,7 @@
                 </a:solidFill>
                 <a:latin typeface="Calibri"/>
               </a:rPr>
-              <a:t>“Artificial intelligence” DECLINED in the 1990s — the AI Winter</a:t>
+              <a:t>In the 1990s, the word “artificial intelligence” went DOWN in books — people lost interest</a:t>
             </a:r>
           </a:p>
           <a:p>
@@ -4679,7 +4679,7 @@
                 </a:solidFill>
                 <a:latin typeface="Calibri"/>
               </a:rPr>
-              <a:t>“Machine learning” rose and overtook it by 2013 — the field quietly rebranded around concrete method</a:t>
+              <a:t>A new word, “machine learning,” became more popular and passed it by 2013</a:t>
             </a:r>
           </a:p>
         </p:txBody>
@@ -4851,7 +4851,7 @@
                 </a:solidFill>
                 <a:latin typeface="Calibri"/>
               </a:rPr>
-              <a:t>Then the explosion — and it's real</a:t>
+              <a:t>Then AI news exploded</a:t>
             </a:r>
           </a:p>
         </p:txBody>
@@ -4902,7 +4902,7 @@
                 </a:solidFill>
                 <a:latin typeface="Calibri"/>
               </a:rPr>
-              <a:t>After AlphaGo (2016) and ChatGPT (2022), AI’s SHARE of all news more than doubled — to ~1% in 2023</a:t>
+              <a:t>After AlphaGo (2016) and ChatGPT (2022), AI news grew very fast — about 1% of ALL news by 2023</a:t>
             </a:r>
           </a:p>
           <a:p>
@@ -4930,7 +4930,7 @@
                 </a:solidFill>
                 <a:latin typeface="Calibri"/>
               </a:rPr>
-              <a:t>I control for total news growth, so this is a genuine shift in attention, not just “more news”</a:t>
+              <a:t>There is more news today in general. But even so, AI grew much, much faster</a:t>
             </a:r>
           </a:p>
         </p:txBody>
@@ -5063,7 +5063,7 @@
                 </a:solidFill>
                 <a:latin typeface="Calibri"/>
               </a:rPr>
-              <a:t>FINDING 3 · THE TWIST</a:t>
+              <a:t>FINDING 3 · THE SURPRISE</a:t>
             </a:r>
           </a:p>
         </p:txBody>
@@ -5102,7 +5102,7 @@
                 </a:solidFill>
                 <a:latin typeface="Calibri"/>
               </a:rPr>
-              <a:t>It was never optimism</a:t>
+              <a:t>People were never happy about AI</a:t>
             </a:r>
           </a:p>
         </p:txBody>
@@ -5153,7 +5153,7 @@
                 </a:solidFill>
                 <a:latin typeface="Calibri"/>
               </a:rPr>
-              <a:t>Tone of AI coverage was NEGATIVE every single year — even in 2010. No optimism to lose.</a:t>
+              <a:t>The news about AI was negative EVERY year — even in 2010. People were never very hopeful</a:t>
             </a:r>
           </a:p>
           <a:p>
@@ -5181,7 +5181,7 @@
                 </a:solidFill>
                 <a:latin typeface="Calibri"/>
               </a:rPr>
-              <a:t>So the shift wasn’t hope → fear. It was SCALE + POLITICAL SALIENCE: AI went from a scientific keyword to a geopolitical one.</a:t>
+              <a:t>The feeling did not change. What changed: AI became (1) a much BIGGER topic, and (2) a POLITICAL one — countries competing, danger, control</a:t>
             </a:r>
           </a:p>
         </p:txBody>
@@ -5314,7 +5314,7 @@
                 </a:solidFill>
                 <a:latin typeface="Calibri"/>
               </a:rPr>
-              <a:t>DOES IT HOLD UP?</a:t>
+              <a:t>IS IT REAL?</a:t>
             </a:r>
           </a:p>
         </p:txBody>
@@ -5353,7 +5353,7 @@
                 </a:solidFill>
                 <a:latin typeface="Calibri"/>
               </a:rPr>
-              <a:t>A second source agrees</a:t>
+              <a:t>I checked with another source</a:t>
             </a:r>
           </a:p>
         </p:txBody>
@@ -5404,7 +5404,7 @@
                 </a:solidFill>
                 <a:latin typeface="Calibri"/>
               </a:rPr>
-              <a:t>To check the 2023 spike is real, I compared it against a separate news database</a:t>
+              <a:t>Is the 2023 rise real, or just a mistake in my data? I compared it with a different news database</a:t>
             </a:r>
           </a:p>
           <a:p>
@@ -5432,7 +5432,7 @@
                 </a:solidFill>
                 <a:latin typeface="Calibri"/>
               </a:rPr>
-              <a:t>The two track closely and land at nearly the same value in 2023 — the surge isn’t a fluke of my data</a:t>
+              <a:t>Both show almost the same result — so the rise is real</a:t>
             </a:r>
           </a:p>
         </p:txBody>
@@ -5609,7 +5609,7 @@
                 </a:solidFill>
                 <a:latin typeface="Calibri"/>
               </a:rPr>
-              <a:t>See the full exhibit — and tell me where it's weak</a:t>
+              <a:t>See my website — and please share your questions</a:t>
             </a:r>
           </a:p>
         </p:txBody>
@@ -5648,7 +5648,7 @@
                 </a:solidFill>
                 <a:latin typeface="Calibri"/>
               </a:rPr>
-              <a:t>Five interactive charts · a GDELT robustness check · full source criticism</a:t>
+              <a:t>More charts and the full story are there</a:t>
             </a:r>
           </a:p>
         </p:txBody>

</xml_diff>

<commit_message>
Mention Atlas of AI by name on slide 2 of the 4-min deck
Co-Authored-By: Claude Opus 4.8 <noreply@anthropic.com>
</commit_message>
<xml_diff>
--- a/ai_discourse_4min.pptx
+++ b/ai_discourse_4min.pptx
@@ -578,7 +578,7 @@
           <a:lstStyle/>
           <a:p>
             <a:r>
-              <a:t>A famous scholar, Kate Crawford, says AI is really about power and control. But she uses ideas, not data. She does not show WHEN people's view of AI changed. So I use data: 30 years of books, and 13 years of news from around the world. I use old AI news as evidence about history. [~45s]</a:t>
+              <a:t>A famous scholar, Kate Crawford, wrote a book called Atlas of AI. She says AI is really about power and control. But she uses ideas, not data. She does not show WHEN people's view of AI changed. So I use data: 30 years of books, and 13 years of news from around the world. I use old AI news as evidence about history. [~45s]</a:t>
             </a:r>
           </a:p>
         </p:txBody>
@@ -4345,7 +4345,7 @@
                 </a:solidFill>
                 <a:latin typeface="Calibri"/>
               </a:rPr>
-              <a:t>Adding data to a famous book</a:t>
+              <a:t>Adding data to Atlas of AI</a:t>
             </a:r>
           </a:p>
         </p:txBody>
@@ -4396,7 +4396,7 @@
                 </a:solidFill>
                 <a:latin typeface="Calibri"/>
               </a:rPr>
-              <a:t>A famous scholar, Kate Crawford, says AI is really about power — but she uses ideas, not data</a:t>
+              <a:t>Kate Crawford’s book Atlas of AI (2021) says AI is really about power — but she uses ideas, not data</a:t>
             </a:r>
           </a:p>
           <a:p>

</xml_diff>

<commit_message>
Add QR code to exhibit; place it on the 4-min closing slide
Co-Authored-By: Claude Opus 4.8 <noreply@anthropic.com>
</commit_message>
<xml_diff>
--- a/ai_discourse_4min.pptx
+++ b/ai_discourse_4min.pptx
@@ -5583,8 +5583,8 @@
         </p:nvSpPr>
         <p:spPr>
           <a:xfrm>
-            <a:off x="914400" y="2011680"/>
-            <a:ext cx="10332720" cy="914400"/>
+            <a:off x="914400" y="868680"/>
+            <a:ext cx="10332720" cy="822960"/>
           </a:xfrm>
           <a:prstGeom prst="rect">
             <a:avLst/>
@@ -5603,7 +5603,7 @@
               </a:lnSpc>
             </a:pPr>
             <a:r>
-              <a:rPr sz="3000" b="1" i="0">
+              <a:rPr sz="2800" b="1" i="0">
                 <a:solidFill>
                   <a:srgbClr val="1A1D24"/>
                 </a:solidFill>
@@ -5622,7 +5622,7 @@
         </p:nvSpPr>
         <p:spPr>
           <a:xfrm>
-            <a:off x="914400" y="3200400"/>
+            <a:off x="914400" y="1783080"/>
             <a:ext cx="10332720" cy="457200"/>
           </a:xfrm>
           <a:prstGeom prst="rect">
@@ -5648,20 +5648,44 @@
                 </a:solidFill>
                 <a:latin typeface="Calibri"/>
               </a:rPr>
-              <a:t>More charts and the full story are there</a:t>
-            </a:r>
-          </a:p>
-        </p:txBody>
-      </p:sp>
-      <p:sp>
-        <p:nvSpPr>
-          <p:cNvPr id="6" name="TextBox 5"/>
+              <a:t>Scan to open the exhibit</a:t>
+            </a:r>
+          </a:p>
+        </p:txBody>
+      </p:sp>
+      <p:pic>
+        <p:nvPicPr>
+          <p:cNvPr id="6" name="Picture 5" descr="qr_exhibit.png"/>
+          <p:cNvPicPr>
+            <a:picLocks noChangeAspect="1"/>
+          </p:cNvPicPr>
+          <p:nvPr/>
+        </p:nvPicPr>
+        <p:blipFill>
+          <a:blip r:embed="rId2"/>
+          <a:stretch>
+            <a:fillRect/>
+          </a:stretch>
+        </p:blipFill>
+        <p:spPr>
+          <a:xfrm>
+            <a:off x="4792827" y="2286000"/>
+            <a:ext cx="2606040" cy="2606040"/>
+          </a:xfrm>
+          <a:prstGeom prst="rect">
+            <a:avLst/>
+          </a:prstGeom>
+        </p:spPr>
+      </p:pic>
+      <p:sp>
+        <p:nvSpPr>
+          <p:cNvPr id="7" name="TextBox 6"/>
           <p:cNvSpPr txBox="1"/>
           <p:nvPr/>
         </p:nvSpPr>
         <p:spPr>
           <a:xfrm>
-            <a:off x="914400" y="3840480"/>
+            <a:off x="914400" y="5120640"/>
             <a:ext cx="10332720" cy="457200"/>
           </a:xfrm>
           <a:prstGeom prst="rect">
@@ -5681,7 +5705,7 @@
               </a:lnSpc>
             </a:pPr>
             <a:r>
-              <a:rPr sz="2200" b="1" i="0">
+              <a:rPr sz="2000" b="1" i="0">
                 <a:solidFill>
                   <a:srgbClr val="2E75B6"/>
                 </a:solidFill>
@@ -5694,13 +5718,13 @@
       </p:sp>
       <p:sp>
         <p:nvSpPr>
-          <p:cNvPr id="7" name="TextBox 6"/>
+          <p:cNvPr id="8" name="TextBox 7"/>
           <p:cNvSpPr txBox="1"/>
           <p:nvPr/>
         </p:nvSpPr>
         <p:spPr>
           <a:xfrm>
-            <a:off x="914400" y="4526280"/>
+            <a:off x="914400" y="5669280"/>
             <a:ext cx="10332720" cy="365760"/>
           </a:xfrm>
           <a:prstGeom prst="rect">

</xml_diff>